<commit_message>
udpating stuff relating to Bayes days of classes
</commit_message>
<xml_diff>
--- a/daily_materials/day23 - Bayesian stats 1/day_23_slides.pptx
+++ b/daily_materials/day23 - Bayesian stats 1/day_23_slides.pptx
@@ -270,7 +270,7 @@
           <a:p>
             <a:fld id="{BA7EE9DC-0C75-CE4D-AE23-1A40179449A0}" type="datetimeFigureOut">
               <a:rPr lang="en-US" smtClean="0"/>
-              <a:t>4/11/21</a:t>
+              <a:t>4/7/26</a:t>
             </a:fld>
             <a:endParaRPr lang="en-US"/>
           </a:p>
@@ -468,7 +468,7 @@
           <a:p>
             <a:fld id="{BA7EE9DC-0C75-CE4D-AE23-1A40179449A0}" type="datetimeFigureOut">
               <a:rPr lang="en-US" smtClean="0"/>
-              <a:t>4/11/21</a:t>
+              <a:t>4/7/26</a:t>
             </a:fld>
             <a:endParaRPr lang="en-US"/>
           </a:p>
@@ -676,7 +676,7 @@
           <a:p>
             <a:fld id="{BA7EE9DC-0C75-CE4D-AE23-1A40179449A0}" type="datetimeFigureOut">
               <a:rPr lang="en-US" smtClean="0"/>
-              <a:t>4/11/21</a:t>
+              <a:t>4/7/26</a:t>
             </a:fld>
             <a:endParaRPr lang="en-US"/>
           </a:p>
@@ -874,7 +874,7 @@
           <a:p>
             <a:fld id="{BA7EE9DC-0C75-CE4D-AE23-1A40179449A0}" type="datetimeFigureOut">
               <a:rPr lang="en-US" smtClean="0"/>
-              <a:t>4/11/21</a:t>
+              <a:t>4/7/26</a:t>
             </a:fld>
             <a:endParaRPr lang="en-US"/>
           </a:p>
@@ -1149,7 +1149,7 @@
           <a:p>
             <a:fld id="{BA7EE9DC-0C75-CE4D-AE23-1A40179449A0}" type="datetimeFigureOut">
               <a:rPr lang="en-US" smtClean="0"/>
-              <a:t>4/11/21</a:t>
+              <a:t>4/7/26</a:t>
             </a:fld>
             <a:endParaRPr lang="en-US"/>
           </a:p>
@@ -1414,7 +1414,7 @@
           <a:p>
             <a:fld id="{BA7EE9DC-0C75-CE4D-AE23-1A40179449A0}" type="datetimeFigureOut">
               <a:rPr lang="en-US" smtClean="0"/>
-              <a:t>4/11/21</a:t>
+              <a:t>4/7/26</a:t>
             </a:fld>
             <a:endParaRPr lang="en-US"/>
           </a:p>
@@ -1826,7 +1826,7 @@
           <a:p>
             <a:fld id="{BA7EE9DC-0C75-CE4D-AE23-1A40179449A0}" type="datetimeFigureOut">
               <a:rPr lang="en-US" smtClean="0"/>
-              <a:t>4/11/21</a:t>
+              <a:t>4/7/26</a:t>
             </a:fld>
             <a:endParaRPr lang="en-US"/>
           </a:p>
@@ -1967,7 +1967,7 @@
           <a:p>
             <a:fld id="{BA7EE9DC-0C75-CE4D-AE23-1A40179449A0}" type="datetimeFigureOut">
               <a:rPr lang="en-US" smtClean="0"/>
-              <a:t>4/11/21</a:t>
+              <a:t>4/7/26</a:t>
             </a:fld>
             <a:endParaRPr lang="en-US"/>
           </a:p>
@@ -2080,7 +2080,7 @@
           <a:p>
             <a:fld id="{BA7EE9DC-0C75-CE4D-AE23-1A40179449A0}" type="datetimeFigureOut">
               <a:rPr lang="en-US" smtClean="0"/>
-              <a:t>4/11/21</a:t>
+              <a:t>4/7/26</a:t>
             </a:fld>
             <a:endParaRPr lang="en-US"/>
           </a:p>
@@ -2391,7 +2391,7 @@
           <a:p>
             <a:fld id="{BA7EE9DC-0C75-CE4D-AE23-1A40179449A0}" type="datetimeFigureOut">
               <a:rPr lang="en-US" smtClean="0"/>
-              <a:t>4/11/21</a:t>
+              <a:t>4/7/26</a:t>
             </a:fld>
             <a:endParaRPr lang="en-US"/>
           </a:p>
@@ -2679,7 +2679,7 @@
           <a:p>
             <a:fld id="{BA7EE9DC-0C75-CE4D-AE23-1A40179449A0}" type="datetimeFigureOut">
               <a:rPr lang="en-US" smtClean="0"/>
-              <a:t>4/11/21</a:t>
+              <a:t>4/7/26</a:t>
             </a:fld>
             <a:endParaRPr lang="en-US"/>
           </a:p>
@@ -2920,7 +2920,7 @@
           <a:p>
             <a:fld id="{BA7EE9DC-0C75-CE4D-AE23-1A40179449A0}" type="datetimeFigureOut">
               <a:rPr lang="en-US" smtClean="0"/>
-              <a:t>4/11/21</a:t>
+              <a:t>4/7/26</a:t>
             </a:fld>
             <a:endParaRPr lang="en-US"/>
           </a:p>
@@ -4077,6 +4077,93 @@
           </a:prstGeom>
         </p:spPr>
       </p:pic>
+      <p:sp>
+        <p:nvSpPr>
+          <p:cNvPr id="2" name="Rectangle 1">
+            <a:extLst>
+              <a:ext uri="{FF2B5EF4-FFF2-40B4-BE49-F238E27FC236}">
+                <a16:creationId xmlns:a16="http://schemas.microsoft.com/office/drawing/2014/main" id="{8F0BD288-41E5-61E0-2789-3ABB7C570C55}"/>
+              </a:ext>
+            </a:extLst>
+          </p:cNvPr>
+          <p:cNvSpPr/>
+          <p:nvPr/>
+        </p:nvSpPr>
+        <p:spPr>
+          <a:xfrm>
+            <a:off x="7878726" y="116958"/>
+            <a:ext cx="4136065" cy="6634716"/>
+          </a:xfrm>
+          <a:prstGeom prst="rect">
+            <a:avLst/>
+          </a:prstGeom>
+          <a:solidFill>
+            <a:schemeClr val="bg1"/>
+          </a:solidFill>
+          <a:ln>
+            <a:noFill/>
+          </a:ln>
+        </p:spPr>
+        <p:style>
+          <a:lnRef idx="2">
+            <a:schemeClr val="accent1">
+              <a:shade val="15000"/>
+            </a:schemeClr>
+          </a:lnRef>
+          <a:fillRef idx="1">
+            <a:schemeClr val="accent1"/>
+          </a:fillRef>
+          <a:effectRef idx="0">
+            <a:schemeClr val="accent1"/>
+          </a:effectRef>
+          <a:fontRef idx="minor">
+            <a:schemeClr val="lt1"/>
+          </a:fontRef>
+        </p:style>
+        <p:txBody>
+          <a:bodyPr rtlCol="0" anchor="ctr"/>
+          <a:lstStyle/>
+          <a:p>
+            <a:pPr algn="ctr"/>
+            <a:endParaRPr lang="en-US" dirty="0"/>
+          </a:p>
+        </p:txBody>
+      </p:sp>
+      <p:sp>
+        <p:nvSpPr>
+          <p:cNvPr id="4" name="TextBox 3">
+            <a:extLst>
+              <a:ext uri="{FF2B5EF4-FFF2-40B4-BE49-F238E27FC236}">
+                <a16:creationId xmlns:a16="http://schemas.microsoft.com/office/drawing/2014/main" id="{391440B0-E9AD-8786-8003-C1119BB025C4}"/>
+              </a:ext>
+            </a:extLst>
+          </p:cNvPr>
+          <p:cNvSpPr txBox="1"/>
+          <p:nvPr/>
+        </p:nvSpPr>
+        <p:spPr>
+          <a:xfrm>
+            <a:off x="8144540" y="531627"/>
+            <a:ext cx="3870251" cy="2585323"/>
+          </a:xfrm>
+          <a:prstGeom prst="rect">
+            <a:avLst/>
+          </a:prstGeom>
+          <a:noFill/>
+        </p:spPr>
+        <p:txBody>
+          <a:bodyPr wrap="square" rtlCol="0">
+            <a:spAutoFit/>
+          </a:bodyPr>
+          <a:lstStyle/>
+          <a:p>
+            <a:r>
+              <a:rPr lang="en-US" dirty="0"/>
+              <a:t>Context: medical tests are essentially never 100% reliable, and some are more reliable than others. Example, flu antigen tests (rapid tests) are only moderately sensitive (50-70% sensitivity, but only 1-5% false positives).  Flu molecular tests are much more sensitive (&gt;90%, with &lt;5% false positives).</a:t>
+            </a:r>
+          </a:p>
+        </p:txBody>
+      </p:sp>
     </p:spTree>
     <p:extLst>
       <p:ext uri="{BB962C8B-B14F-4D97-AF65-F5344CB8AC3E}">

</xml_diff>